<commit_message>
Updated JobShield AI website and features
</commit_message>
<xml_diff>
--- a/JobShield_AI_Hackathon_Pitch.pptx
+++ b/JobShield_AI_Hackathon_Pitch.pptx
@@ -5,15 +5,15 @@
     <p:sldMasterId id="2147483648" r:id="rId1"/>
   </p:sldMasterIdLst>
   <p:sldIdLst>
-    <p:sldId id="256" r:id="rId7"/>
-    <p:sldId id="257" r:id="rId8"/>
-    <p:sldId id="258" r:id="rId9"/>
-    <p:sldId id="259" r:id="rId10"/>
-    <p:sldId id="260" r:id="rId11"/>
-    <p:sldId id="261" r:id="rId12"/>
-    <p:sldId id="262" r:id="rId13"/>
+    <p:sldId id="256" r:id="rId2"/>
+    <p:sldId id="257" r:id="rId3"/>
+    <p:sldId id="258" r:id="rId4"/>
+    <p:sldId id="259" r:id="rId5"/>
+    <p:sldId id="260" r:id="rId6"/>
+    <p:sldId id="261" r:id="rId7"/>
+    <p:sldId id="262" r:id="rId8"/>
   </p:sldIdLst>
-  <p:sldSz cx="12191695" cy="6858000" type="screen4x3"/>
+  <p:sldSz cx="12192000" cy="6858000"/>
   <p:notesSz cx="6858000" cy="9144000"/>
   <p:defaultTextStyle>
     <a:defPPr>
@@ -110,6 +110,22 @@
       </a:defRPr>
     </a:lvl9pPr>
   </p:defaultTextStyle>
+  <p:extLst>
+    <p:ext uri="{EFAFB233-063F-42B5-8137-9DF3F51BA10A}">
+      <p15:sldGuideLst xmlns:p15="http://schemas.microsoft.com/office/powerpoint/2012/main">
+        <p15:guide id="1" orient="horz" pos="2160">
+          <p15:clr>
+            <a:srgbClr val="A4A3A4"/>
+          </p15:clr>
+        </p15:guide>
+        <p15:guide id="2" pos="2880">
+          <p15:clr>
+            <a:srgbClr val="A4A3A4"/>
+          </p15:clr>
+        </p15:guide>
+      </p15:sldGuideLst>
+    </p:ext>
+  </p:extLst>
 </p:presentation>
 </file>
 
@@ -294,7 +310,7 @@
           <a:p>
             <a:fld id="{5BCAD085-E8A6-8845-BD4E-CB4CCA059FC4}" type="datetimeFigureOut">
               <a:rPr lang="en-US" smtClean="0"/>
-              <a:t>1/27/13</a:t>
+              <a:t>10/23/2026</a:t>
             </a:fld>
             <a:endParaRPr lang="en-US"/>
           </a:p>
@@ -464,7 +480,7 @@
           <a:p>
             <a:fld id="{5BCAD085-E8A6-8845-BD4E-CB4CCA059FC4}" type="datetimeFigureOut">
               <a:rPr lang="en-US" smtClean="0"/>
-              <a:t>1/27/13</a:t>
+              <a:t>10/23/2026</a:t>
             </a:fld>
             <a:endParaRPr lang="en-US"/>
           </a:p>
@@ -644,7 +660,7 @@
           <a:p>
             <a:fld id="{5BCAD085-E8A6-8845-BD4E-CB4CCA059FC4}" type="datetimeFigureOut">
               <a:rPr lang="en-US" smtClean="0"/>
-              <a:t>1/27/13</a:t>
+              <a:t>10/23/2026</a:t>
             </a:fld>
             <a:endParaRPr lang="en-US"/>
           </a:p>
@@ -814,7 +830,7 @@
           <a:p>
             <a:fld id="{5BCAD085-E8A6-8845-BD4E-CB4CCA059FC4}" type="datetimeFigureOut">
               <a:rPr lang="en-US" smtClean="0"/>
-              <a:t>1/27/13</a:t>
+              <a:t>10/23/2026</a:t>
             </a:fld>
             <a:endParaRPr lang="en-US"/>
           </a:p>
@@ -1060,7 +1076,7 @@
           <a:p>
             <a:fld id="{5BCAD085-E8A6-8845-BD4E-CB4CCA059FC4}" type="datetimeFigureOut">
               <a:rPr lang="en-US" smtClean="0"/>
-              <a:t>1/27/13</a:t>
+              <a:t>10/23/2026</a:t>
             </a:fld>
             <a:endParaRPr lang="en-US"/>
           </a:p>
@@ -1348,7 +1364,7 @@
           <a:p>
             <a:fld id="{5BCAD085-E8A6-8845-BD4E-CB4CCA059FC4}" type="datetimeFigureOut">
               <a:rPr lang="en-US" smtClean="0"/>
-              <a:t>1/27/13</a:t>
+              <a:t>10/23/2026</a:t>
             </a:fld>
             <a:endParaRPr lang="en-US"/>
           </a:p>
@@ -1770,7 +1786,7 @@
           <a:p>
             <a:fld id="{5BCAD085-E8A6-8845-BD4E-CB4CCA059FC4}" type="datetimeFigureOut">
               <a:rPr lang="en-US" smtClean="0"/>
-              <a:t>1/27/13</a:t>
+              <a:t>10/23/2026</a:t>
             </a:fld>
             <a:endParaRPr lang="en-US"/>
           </a:p>
@@ -1888,7 +1904,7 @@
           <a:p>
             <a:fld id="{5BCAD085-E8A6-8845-BD4E-CB4CCA059FC4}" type="datetimeFigureOut">
               <a:rPr lang="en-US" smtClean="0"/>
-              <a:t>1/27/13</a:t>
+              <a:t>10/23/2026</a:t>
             </a:fld>
             <a:endParaRPr lang="en-US"/>
           </a:p>
@@ -1983,7 +1999,7 @@
           <a:p>
             <a:fld id="{5BCAD085-E8A6-8845-BD4E-CB4CCA059FC4}" type="datetimeFigureOut">
               <a:rPr lang="en-US" smtClean="0"/>
-              <a:t>1/27/13</a:t>
+              <a:t>10/23/2026</a:t>
             </a:fld>
             <a:endParaRPr lang="en-US"/>
           </a:p>
@@ -2260,7 +2276,7 @@
           <a:p>
             <a:fld id="{5BCAD085-E8A6-8845-BD4E-CB4CCA059FC4}" type="datetimeFigureOut">
               <a:rPr lang="en-US" smtClean="0"/>
-              <a:t>1/27/13</a:t>
+              <a:t>10/23/2026</a:t>
             </a:fld>
             <a:endParaRPr lang="en-US"/>
           </a:p>
@@ -2513,7 +2529,7 @@
           <a:p>
             <a:fld id="{5BCAD085-E8A6-8845-BD4E-CB4CCA059FC4}" type="datetimeFigureOut">
               <a:rPr lang="en-US" smtClean="0"/>
-              <a:t>1/27/13</a:t>
+              <a:t>10/23/2026</a:t>
             </a:fld>
             <a:endParaRPr lang="en-US"/>
           </a:p>
@@ -2726,7 +2742,7 @@
           <a:p>
             <a:fld id="{5BCAD085-E8A6-8845-BD4E-CB4CCA059FC4}" type="datetimeFigureOut">
               <a:rPr lang="en-US" smtClean="0"/>
-              <a:t>1/27/13</a:t>
+              <a:t>10/23/2026</a:t>
             </a:fld>
             <a:endParaRPr lang="en-US"/>
           </a:p>
@@ -3085,7 +3101,7 @@
 </file>
 
 <file path=ppt/slides/slide1.xml><?xml version="1.0" encoding="utf-8"?>
-<p:sld xmlns:a="http://schemas.openxmlformats.org/drawingml/2006/main" xmlns:p="http://schemas.openxmlformats.org/presentationml/2006/main" xmlns:r="http://schemas.openxmlformats.org/officeDocument/2006/relationships">
+<p:sld xmlns:a="http://schemas.openxmlformats.org/drawingml/2006/main" xmlns:r="http://schemas.openxmlformats.org/officeDocument/2006/relationships" xmlns:p="http://schemas.openxmlformats.org/presentationml/2006/main">
   <p:cSld>
     <p:spTree>
       <p:nvGrpSpPr>
@@ -3093,7 +3109,14 @@
         <p:cNvGrpSpPr/>
         <p:nvPr/>
       </p:nvGrpSpPr>
-      <p:grpSpPr/>
+      <p:grpSpPr>
+        <a:xfrm>
+          <a:off x="0" y="0"/>
+          <a:ext cx="0" cy="0"/>
+          <a:chOff x="0" y="0"/>
+          <a:chExt cx="0" cy="0"/>
+        </a:xfrm>
+      </p:grpSpPr>
       <p:sp>
         <p:nvSpPr>
           <p:cNvPr id="2" name="Rectangle 1"/>
@@ -3134,6 +3157,7 @@
           <a:lstStyle/>
           <a:p>
             <a:pPr algn="ctr"/>
+            <a:endParaRPr/>
           </a:p>
         </p:txBody>
       </p:sp>
@@ -3177,6 +3201,7 @@
           <a:lstStyle/>
           <a:p>
             <a:pPr algn="ctr"/>
+            <a:endParaRPr/>
           </a:p>
         </p:txBody>
       </p:sp>
@@ -3370,6 +3395,7 @@
           <a:lstStyle/>
           <a:p>
             <a:pPr algn="ctr"/>
+            <a:endParaRPr/>
           </a:p>
         </p:txBody>
       </p:sp>
@@ -3516,6 +3542,7 @@
           <a:lstStyle/>
           <a:p>
             <a:pPr algn="ctr"/>
+            <a:endParaRPr/>
           </a:p>
         </p:txBody>
       </p:sp>
@@ -3662,6 +3689,7 @@
           <a:lstStyle/>
           <a:p>
             <a:pPr algn="ctr"/>
+            <a:endParaRPr/>
           </a:p>
         </p:txBody>
       </p:sp>
@@ -3808,6 +3836,7 @@
           <a:lstStyle/>
           <a:p>
             <a:pPr algn="ctr"/>
+            <a:endParaRPr/>
           </a:p>
         </p:txBody>
       </p:sp>
@@ -3954,6 +3983,7 @@
           <a:lstStyle/>
           <a:p>
             <a:pPr algn="ctr"/>
+            <a:endParaRPr/>
           </a:p>
         </p:txBody>
       </p:sp>
@@ -4100,6 +4130,7 @@
           <a:lstStyle/>
           <a:p>
             <a:pPr algn="ctr"/>
+            <a:endParaRPr/>
           </a:p>
         </p:txBody>
       </p:sp>
@@ -4213,7 +4244,7 @@
 </file>
 
 <file path=ppt/slides/slide2.xml><?xml version="1.0" encoding="utf-8"?>
-<p:sld xmlns:a="http://schemas.openxmlformats.org/drawingml/2006/main" xmlns:p="http://schemas.openxmlformats.org/presentationml/2006/main" xmlns:r="http://schemas.openxmlformats.org/officeDocument/2006/relationships">
+<p:sld xmlns:a="http://schemas.openxmlformats.org/drawingml/2006/main" xmlns:r="http://schemas.openxmlformats.org/officeDocument/2006/relationships" xmlns:p="http://schemas.openxmlformats.org/presentationml/2006/main">
   <p:cSld>
     <p:spTree>
       <p:nvGrpSpPr>
@@ -4221,7 +4252,14 @@
         <p:cNvGrpSpPr/>
         <p:nvPr/>
       </p:nvGrpSpPr>
-      <p:grpSpPr/>
+      <p:grpSpPr>
+        <a:xfrm>
+          <a:off x="0" y="0"/>
+          <a:ext cx="0" cy="0"/>
+          <a:chOff x="0" y="0"/>
+          <a:chExt cx="0" cy="0"/>
+        </a:xfrm>
+      </p:grpSpPr>
       <p:sp>
         <p:nvSpPr>
           <p:cNvPr id="2" name="Rectangle 1"/>
@@ -4262,6 +4300,7 @@
           <a:lstStyle/>
           <a:p>
             <a:pPr algn="ctr"/>
+            <a:endParaRPr/>
           </a:p>
         </p:txBody>
       </p:sp>
@@ -4377,6 +4416,7 @@
           <a:lstStyle/>
           <a:p>
             <a:pPr algn="ctr"/>
+            <a:endParaRPr/>
           </a:p>
         </p:txBody>
       </p:sp>
@@ -4420,6 +4460,7 @@
           <a:lstStyle/>
           <a:p>
             <a:pPr algn="ctr"/>
+            <a:endParaRPr/>
           </a:p>
         </p:txBody>
       </p:sp>
@@ -4512,6 +4553,7 @@
           <a:lstStyle/>
           <a:p>
             <a:pPr algn="ctr"/>
+            <a:endParaRPr/>
           </a:p>
         </p:txBody>
       </p:sp>
@@ -4555,6 +4597,7 @@
           <a:lstStyle/>
           <a:p>
             <a:pPr algn="ctr"/>
+            <a:endParaRPr/>
           </a:p>
         </p:txBody>
       </p:sp>
@@ -4647,6 +4690,7 @@
           <a:lstStyle/>
           <a:p>
             <a:pPr algn="ctr"/>
+            <a:endParaRPr/>
           </a:p>
         </p:txBody>
       </p:sp>
@@ -4690,6 +4734,7 @@
           <a:lstStyle/>
           <a:p>
             <a:pPr algn="ctr"/>
+            <a:endParaRPr/>
           </a:p>
         </p:txBody>
       </p:sp>
@@ -4782,6 +4827,7 @@
           <a:lstStyle/>
           <a:p>
             <a:pPr algn="ctr"/>
+            <a:endParaRPr/>
           </a:p>
         </p:txBody>
       </p:sp>
@@ -4801,7 +4847,7 @@
         </p:blipFill>
         <p:spPr>
           <a:xfrm>
-            <a:off x="5394960" y="1554480"/>
+            <a:off x="5377030" y="2585437"/>
             <a:ext cx="5943600" cy="2364063"/>
           </a:xfrm>
           <a:prstGeom prst="rect">
@@ -4818,7 +4864,7 @@
 </file>
 
 <file path=ppt/slides/slide3.xml><?xml version="1.0" encoding="utf-8"?>
-<p:sld xmlns:a="http://schemas.openxmlformats.org/drawingml/2006/main" xmlns:p="http://schemas.openxmlformats.org/presentationml/2006/main" xmlns:r="http://schemas.openxmlformats.org/officeDocument/2006/relationships">
+<p:sld xmlns:a="http://schemas.openxmlformats.org/drawingml/2006/main" xmlns:r="http://schemas.openxmlformats.org/officeDocument/2006/relationships" xmlns:p="http://schemas.openxmlformats.org/presentationml/2006/main">
   <p:cSld>
     <p:spTree>
       <p:nvGrpSpPr>
@@ -4826,7 +4872,14 @@
         <p:cNvGrpSpPr/>
         <p:nvPr/>
       </p:nvGrpSpPr>
-      <p:grpSpPr/>
+      <p:grpSpPr>
+        <a:xfrm>
+          <a:off x="0" y="0"/>
+          <a:ext cx="0" cy="0"/>
+          <a:chOff x="0" y="0"/>
+          <a:chExt cx="0" cy="0"/>
+        </a:xfrm>
+      </p:grpSpPr>
       <p:sp>
         <p:nvSpPr>
           <p:cNvPr id="2" name="Rectangle 1"/>
@@ -4867,6 +4920,7 @@
           <a:lstStyle/>
           <a:p>
             <a:pPr algn="ctr"/>
+            <a:endParaRPr/>
           </a:p>
         </p:txBody>
       </p:sp>
@@ -4982,6 +5036,7 @@
           <a:lstStyle/>
           <a:p>
             <a:pPr algn="ctr"/>
+            <a:endParaRPr/>
           </a:p>
         </p:txBody>
       </p:sp>
@@ -5025,6 +5080,7 @@
           <a:lstStyle/>
           <a:p>
             <a:pPr algn="ctr"/>
+            <a:endParaRPr/>
           </a:p>
         </p:txBody>
       </p:sp>
@@ -5171,6 +5227,7 @@
           <a:lstStyle/>
           <a:p>
             <a:pPr algn="ctr"/>
+            <a:endParaRPr/>
           </a:p>
         </p:txBody>
       </p:sp>
@@ -5214,6 +5271,7 @@
           <a:lstStyle/>
           <a:p>
             <a:pPr algn="ctr"/>
+            <a:endParaRPr/>
           </a:p>
         </p:txBody>
       </p:sp>
@@ -5360,6 +5418,7 @@
           <a:lstStyle/>
           <a:p>
             <a:pPr algn="ctr"/>
+            <a:endParaRPr/>
           </a:p>
         </p:txBody>
       </p:sp>
@@ -5403,6 +5462,7 @@
           <a:lstStyle/>
           <a:p>
             <a:pPr algn="ctr"/>
+            <a:endParaRPr/>
           </a:p>
         </p:txBody>
       </p:sp>
@@ -5549,6 +5609,7 @@
           <a:lstStyle/>
           <a:p>
             <a:pPr algn="ctr"/>
+            <a:endParaRPr/>
           </a:p>
         </p:txBody>
       </p:sp>
@@ -5592,6 +5653,7 @@
           <a:lstStyle/>
           <a:p>
             <a:pPr algn="ctr"/>
+            <a:endParaRPr/>
           </a:p>
         </p:txBody>
       </p:sp>
@@ -5705,7 +5767,7 @@
 </file>
 
 <file path=ppt/slides/slide4.xml><?xml version="1.0" encoding="utf-8"?>
-<p:sld xmlns:a="http://schemas.openxmlformats.org/drawingml/2006/main" xmlns:p="http://schemas.openxmlformats.org/presentationml/2006/main" xmlns:r="http://schemas.openxmlformats.org/officeDocument/2006/relationships">
+<p:sld xmlns:a="http://schemas.openxmlformats.org/drawingml/2006/main" xmlns:r="http://schemas.openxmlformats.org/officeDocument/2006/relationships" xmlns:p="http://schemas.openxmlformats.org/presentationml/2006/main">
   <p:cSld>
     <p:spTree>
       <p:nvGrpSpPr>
@@ -5713,7 +5775,14 @@
         <p:cNvGrpSpPr/>
         <p:nvPr/>
       </p:nvGrpSpPr>
-      <p:grpSpPr/>
+      <p:grpSpPr>
+        <a:xfrm>
+          <a:off x="0" y="0"/>
+          <a:ext cx="0" cy="0"/>
+          <a:chOff x="0" y="0"/>
+          <a:chExt cx="0" cy="0"/>
+        </a:xfrm>
+      </p:grpSpPr>
       <p:sp>
         <p:nvSpPr>
           <p:cNvPr id="2" name="Rectangle 1"/>
@@ -5754,6 +5823,7 @@
           <a:lstStyle/>
           <a:p>
             <a:pPr algn="ctr"/>
+            <a:endParaRPr/>
           </a:p>
         </p:txBody>
       </p:sp>
@@ -5869,6 +5939,7 @@
           <a:lstStyle/>
           <a:p>
             <a:pPr algn="ctr"/>
+            <a:endParaRPr/>
           </a:p>
         </p:txBody>
       </p:sp>
@@ -6070,6 +6141,7 @@
           <a:lstStyle/>
           <a:p>
             <a:pPr algn="ctr"/>
+            <a:endParaRPr/>
           </a:p>
         </p:txBody>
       </p:sp>
@@ -6271,6 +6343,7 @@
           <a:lstStyle/>
           <a:p>
             <a:pPr algn="ctr"/>
+            <a:endParaRPr/>
           </a:p>
         </p:txBody>
       </p:sp>
@@ -6472,6 +6545,7 @@
           <a:lstStyle/>
           <a:p>
             <a:pPr algn="ctr"/>
+            <a:endParaRPr/>
           </a:p>
         </p:txBody>
       </p:sp>
@@ -6638,6 +6712,7 @@
           <a:lstStyle/>
           <a:p>
             <a:pPr algn="ctr"/>
+            <a:endParaRPr/>
           </a:p>
         </p:txBody>
       </p:sp>
@@ -6826,7 +6901,7 @@
 </file>
 
 <file path=ppt/slides/slide5.xml><?xml version="1.0" encoding="utf-8"?>
-<p:sld xmlns:a="http://schemas.openxmlformats.org/drawingml/2006/main" xmlns:p="http://schemas.openxmlformats.org/presentationml/2006/main" xmlns:r="http://schemas.openxmlformats.org/officeDocument/2006/relationships">
+<p:sld xmlns:a="http://schemas.openxmlformats.org/drawingml/2006/main" xmlns:r="http://schemas.openxmlformats.org/officeDocument/2006/relationships" xmlns:p="http://schemas.openxmlformats.org/presentationml/2006/main">
   <p:cSld>
     <p:spTree>
       <p:nvGrpSpPr>
@@ -6834,7 +6909,14 @@
         <p:cNvGrpSpPr/>
         <p:nvPr/>
       </p:nvGrpSpPr>
-      <p:grpSpPr/>
+      <p:grpSpPr>
+        <a:xfrm>
+          <a:off x="0" y="0"/>
+          <a:ext cx="0" cy="0"/>
+          <a:chOff x="0" y="0"/>
+          <a:chExt cx="0" cy="0"/>
+        </a:xfrm>
+      </p:grpSpPr>
       <p:sp>
         <p:nvSpPr>
           <p:cNvPr id="2" name="Rectangle 1"/>
@@ -6875,6 +6957,7 @@
           <a:lstStyle/>
           <a:p>
             <a:pPr algn="ctr"/>
+            <a:endParaRPr/>
           </a:p>
         </p:txBody>
       </p:sp>
@@ -6967,9 +7050,27 @@
                 <a:tableStyleId>{5C22544A-7EE6-4342-B048-85BDC9FD1C3A}</a:tableStyleId>
               </a:tblPr>
               <a:tblGrid>
-                <a:gridCol w="2926080"/>
-                <a:gridCol w="3840480"/>
-                <a:gridCol w="3959352"/>
+                <a:gridCol w="2926080">
+                  <a:extLst>
+                    <a:ext uri="{9D8B030D-6E8A-4147-A177-3AD203B41FA5}">
+                      <a16:colId xmlns:a16="http://schemas.microsoft.com/office/drawing/2014/main" val="20000"/>
+                    </a:ext>
+                  </a:extLst>
+                </a:gridCol>
+                <a:gridCol w="3840480">
+                  <a:extLst>
+                    <a:ext uri="{9D8B030D-6E8A-4147-A177-3AD203B41FA5}">
+                      <a16:colId xmlns:a16="http://schemas.microsoft.com/office/drawing/2014/main" val="20001"/>
+                    </a:ext>
+                  </a:extLst>
+                </a:gridCol>
+                <a:gridCol w="3959352">
+                  <a:extLst>
+                    <a:ext uri="{9D8B030D-6E8A-4147-A177-3AD203B41FA5}">
+                      <a16:colId xmlns:a16="http://schemas.microsoft.com/office/drawing/2014/main" val="20002"/>
+                    </a:ext>
+                  </a:extLst>
+                </a:gridCol>
               </a:tblGrid>
               <a:tr h="746760">
                 <a:tc>
@@ -7041,6 +7142,11 @@
                     </a:solidFill>
                   </a:tcPr>
                 </a:tc>
+                <a:extLst>
+                  <a:ext uri="{0D108BD9-81ED-4DB2-BD59-A6C34878D82A}">
+                    <a16:rowId xmlns:a16="http://schemas.microsoft.com/office/drawing/2014/main" val="10000"/>
+                  </a:ext>
+                </a:extLst>
               </a:tr>
               <a:tr h="746760">
                 <a:tc>
@@ -7112,6 +7218,11 @@
                     </a:solidFill>
                   </a:tcPr>
                 </a:tc>
+                <a:extLst>
+                  <a:ext uri="{0D108BD9-81ED-4DB2-BD59-A6C34878D82A}">
+                    <a16:rowId xmlns:a16="http://schemas.microsoft.com/office/drawing/2014/main" val="10001"/>
+                  </a:ext>
+                </a:extLst>
               </a:tr>
               <a:tr h="746760">
                 <a:tc>
@@ -7183,6 +7294,11 @@
                     </a:solidFill>
                   </a:tcPr>
                 </a:tc>
+                <a:extLst>
+                  <a:ext uri="{0D108BD9-81ED-4DB2-BD59-A6C34878D82A}">
+                    <a16:rowId xmlns:a16="http://schemas.microsoft.com/office/drawing/2014/main" val="10002"/>
+                  </a:ext>
+                </a:extLst>
               </a:tr>
               <a:tr h="746760">
                 <a:tc>
@@ -7254,6 +7370,11 @@
                     </a:solidFill>
                   </a:tcPr>
                 </a:tc>
+                <a:extLst>
+                  <a:ext uri="{0D108BD9-81ED-4DB2-BD59-A6C34878D82A}">
+                    <a16:rowId xmlns:a16="http://schemas.microsoft.com/office/drawing/2014/main" val="10003"/>
+                  </a:ext>
+                </a:extLst>
               </a:tr>
               <a:tr h="746760">
                 <a:tc>
@@ -7325,6 +7446,11 @@
                     </a:solidFill>
                   </a:tcPr>
                 </a:tc>
+                <a:extLst>
+                  <a:ext uri="{0D108BD9-81ED-4DB2-BD59-A6C34878D82A}">
+                    <a16:rowId xmlns:a16="http://schemas.microsoft.com/office/drawing/2014/main" val="10004"/>
+                  </a:ext>
+                </a:extLst>
               </a:tr>
               <a:tr h="746760">
                 <a:tc>
@@ -7396,6 +7522,11 @@
                     </a:solidFill>
                   </a:tcPr>
                 </a:tc>
+                <a:extLst>
+                  <a:ext uri="{0D108BD9-81ED-4DB2-BD59-A6C34878D82A}">
+                    <a16:rowId xmlns:a16="http://schemas.microsoft.com/office/drawing/2014/main" val="10005"/>
+                  </a:ext>
+                </a:extLst>
               </a:tr>
             </a:tbl>
           </a:graphicData>
@@ -7410,7 +7541,7 @@
 </file>
 
 <file path=ppt/slides/slide6.xml><?xml version="1.0" encoding="utf-8"?>
-<p:sld xmlns:a="http://schemas.openxmlformats.org/drawingml/2006/main" xmlns:p="http://schemas.openxmlformats.org/presentationml/2006/main" xmlns:r="http://schemas.openxmlformats.org/officeDocument/2006/relationships">
+<p:sld xmlns:a="http://schemas.openxmlformats.org/drawingml/2006/main" xmlns:r="http://schemas.openxmlformats.org/officeDocument/2006/relationships" xmlns:p="http://schemas.openxmlformats.org/presentationml/2006/main">
   <p:cSld>
     <p:spTree>
       <p:nvGrpSpPr>
@@ -7418,7 +7549,14 @@
         <p:cNvGrpSpPr/>
         <p:nvPr/>
       </p:nvGrpSpPr>
-      <p:grpSpPr/>
+      <p:grpSpPr>
+        <a:xfrm>
+          <a:off x="0" y="0"/>
+          <a:ext cx="0" cy="0"/>
+          <a:chOff x="0" y="0"/>
+          <a:chExt cx="0" cy="0"/>
+        </a:xfrm>
+      </p:grpSpPr>
       <p:sp>
         <p:nvSpPr>
           <p:cNvPr id="2" name="Rectangle 1"/>
@@ -7459,6 +7597,7 @@
           <a:lstStyle/>
           <a:p>
             <a:pPr algn="ctr"/>
+            <a:endParaRPr/>
           </a:p>
         </p:txBody>
       </p:sp>
@@ -7574,6 +7713,7 @@
           <a:lstStyle/>
           <a:p>
             <a:pPr algn="ctr"/>
+            <a:endParaRPr/>
           </a:p>
         </p:txBody>
       </p:sp>
@@ -7593,8 +7733,8 @@
         </p:blipFill>
         <p:spPr>
           <a:xfrm>
-            <a:off x="914400" y="1645920"/>
-            <a:ext cx="4846320" cy="3069336"/>
+            <a:off x="1004049" y="1790671"/>
+            <a:ext cx="4688541" cy="2969409"/>
           </a:xfrm>
           <a:prstGeom prst="rect">
             <a:avLst/>
@@ -7609,7 +7749,7 @@
         </p:nvSpPr>
         <p:spPr>
           <a:xfrm>
-            <a:off x="914400" y="4114800"/>
+            <a:off x="1097280" y="4924044"/>
             <a:ext cx="4846320" cy="2011680"/>
           </a:xfrm>
           <a:prstGeom prst="rect">
@@ -7631,7 +7771,12 @@
               </a:defRPr>
             </a:pPr>
             <a:r>
-              <a:t>JobShield AI Detected Threat Indicators:</a:t>
+              <a:rPr dirty="0" err="1"/>
+              <a:t>JobShield</a:t>
+            </a:r>
+            <a:r>
+              <a:rPr dirty="0"/>
+              <a:t> AI Detected Threat Indicators:</a:t>
             </a:r>
           </a:p>
           <a:p>
@@ -7643,7 +7788,16 @@
               </a:defRPr>
             </a:pPr>
             <a:r>
-              <a:t>🚩 Upfront Extortion: Demands Rs. 499 deposit before work begins.</a:t>
+              <a:rPr dirty="0"/>
+              <a:t>🚩 Upfront Extortion: Demands </a:t>
+            </a:r>
+            <a:r>
+              <a:rPr dirty="0" err="1"/>
+              <a:t>Rs</a:t>
+            </a:r>
+            <a:r>
+              <a:rPr dirty="0"/>
+              <a:t>. 499 deposit before work begins.</a:t>
             </a:r>
           </a:p>
           <a:p>
@@ -7655,7 +7809,16 @@
               </a:defRPr>
             </a:pPr>
             <a:r>
-              <a:t>🚩 Impossible Wage Ratio: Rs. 5,000/day for casual video clicks.</a:t>
+              <a:rPr dirty="0"/>
+              <a:t>🚩 Impossible Wage Ratio: </a:t>
+            </a:r>
+            <a:r>
+              <a:rPr dirty="0" err="1"/>
+              <a:t>Rs</a:t>
+            </a:r>
+            <a:r>
+              <a:rPr dirty="0"/>
+              <a:t>. 5,000/day for casual video clicks.</a:t>
             </a:r>
           </a:p>
           <a:p>
@@ -7667,6 +7830,7 @@
               </a:defRPr>
             </a:pPr>
             <a:r>
+              <a:rPr dirty="0"/>
               <a:t>🚩 Anonymous Routing: Directs students to Telegram instead of domain.</a:t>
             </a:r>
           </a:p>
@@ -7714,6 +7878,7 @@
           <a:lstStyle/>
           <a:p>
             <a:pPr algn="ctr"/>
+            <a:endParaRPr/>
           </a:p>
         </p:txBody>
       </p:sp>
@@ -7733,8 +7898,8 @@
         </p:blipFill>
         <p:spPr>
           <a:xfrm>
-            <a:off x="6400800" y="1645920"/>
-            <a:ext cx="4846320" cy="3069336"/>
+            <a:off x="6454590" y="1824140"/>
+            <a:ext cx="4706471" cy="2980765"/>
           </a:xfrm>
           <a:prstGeom prst="rect">
             <a:avLst/>
@@ -7749,7 +7914,7 @@
         </p:nvSpPr>
         <p:spPr>
           <a:xfrm>
-            <a:off x="6400800" y="4114800"/>
+            <a:off x="6675120" y="4957572"/>
             <a:ext cx="4846320" cy="2011680"/>
           </a:xfrm>
           <a:prstGeom prst="rect">
@@ -7771,7 +7936,12 @@
               </a:defRPr>
             </a:pPr>
             <a:r>
-              <a:t>JobShield AI Verified Safety Metrics:</a:t>
+              <a:rPr dirty="0" err="1"/>
+              <a:t>JobShield</a:t>
+            </a:r>
+            <a:r>
+              <a:rPr dirty="0"/>
+              <a:t> AI Verified Safety Metrics:</a:t>
             </a:r>
           </a:p>
           <a:p>
@@ -7783,6 +7953,7 @@
               </a:defRPr>
             </a:pPr>
             <a:r>
+              <a:rPr dirty="0"/>
               <a:t>🛡️ Established Domain Authority: tcs.com registered &gt; 25 years ago.</a:t>
             </a:r>
           </a:p>
@@ -7795,6 +7966,7 @@
               </a:defRPr>
             </a:pPr>
             <a:r>
+              <a:rPr dirty="0"/>
               <a:t>🛡️ Zero Fee Policy: Explicit disclaimer against monetary demands.</a:t>
             </a:r>
           </a:p>
@@ -7807,7 +7979,16 @@
               </a:defRPr>
             </a:pPr>
             <a:r>
-              <a:t>🛡️ Official Corporate Gateway: Directs to standard NextStep portal.</a:t>
+              <a:rPr dirty="0"/>
+              <a:t>🛡️ Official Corporate Gateway: Directs to standard </a:t>
+            </a:r>
+            <a:r>
+              <a:rPr dirty="0" err="1"/>
+              <a:t>NextStep</a:t>
+            </a:r>
+            <a:r>
+              <a:rPr dirty="0"/>
+              <a:t> portal.</a:t>
             </a:r>
           </a:p>
         </p:txBody>
@@ -7821,7 +8002,7 @@
 </file>
 
 <file path=ppt/slides/slide7.xml><?xml version="1.0" encoding="utf-8"?>
-<p:sld xmlns:a="http://schemas.openxmlformats.org/drawingml/2006/main" xmlns:p="http://schemas.openxmlformats.org/presentationml/2006/main" xmlns:r="http://schemas.openxmlformats.org/officeDocument/2006/relationships">
+<p:sld xmlns:a="http://schemas.openxmlformats.org/drawingml/2006/main" xmlns:r="http://schemas.openxmlformats.org/officeDocument/2006/relationships" xmlns:p="http://schemas.openxmlformats.org/presentationml/2006/main">
   <p:cSld>
     <p:spTree>
       <p:nvGrpSpPr>
@@ -7829,7 +8010,14 @@
         <p:cNvGrpSpPr/>
         <p:nvPr/>
       </p:nvGrpSpPr>
-      <p:grpSpPr/>
+      <p:grpSpPr>
+        <a:xfrm>
+          <a:off x="0" y="0"/>
+          <a:ext cx="0" cy="0"/>
+          <a:chOff x="0" y="0"/>
+          <a:chExt cx="0" cy="0"/>
+        </a:xfrm>
+      </p:grpSpPr>
       <p:sp>
         <p:nvSpPr>
           <p:cNvPr id="2" name="Rectangle 1"/>
@@ -7870,6 +8058,7 @@
           <a:lstStyle/>
           <a:p>
             <a:pPr algn="ctr"/>
+            <a:endParaRPr/>
           </a:p>
         </p:txBody>
       </p:sp>
@@ -7981,7 +8170,7 @@
           </a:fontRef>
         </p:style>
         <p:txBody>
-          <a:bodyPr rtlCol="0" anchor="ctr" wrap="square"/>
+          <a:bodyPr wrap="square" rtlCol="0" anchor="ctr"/>
           <a:lstStyle/>
           <a:p>
             <a:pPr algn="ctr">
@@ -8047,7 +8236,7 @@
           </a:fontRef>
         </p:style>
         <p:txBody>
-          <a:bodyPr rtlCol="0" anchor="ctr" wrap="square"/>
+          <a:bodyPr wrap="square" rtlCol="0" anchor="ctr"/>
           <a:lstStyle/>
           <a:p>
             <a:pPr algn="ctr">
@@ -8113,7 +8302,7 @@
           </a:fontRef>
         </p:style>
         <p:txBody>
-          <a:bodyPr rtlCol="0" anchor="ctr" wrap="square"/>
+          <a:bodyPr wrap="square" rtlCol="0" anchor="ctr"/>
           <a:lstStyle/>
           <a:p>
             <a:pPr algn="ctr">
@@ -8179,7 +8368,7 @@
           </a:fontRef>
         </p:style>
         <p:txBody>
-          <a:bodyPr rtlCol="0" anchor="ctr" wrap="square"/>
+          <a:bodyPr wrap="square" rtlCol="0" anchor="ctr"/>
           <a:lstStyle/>
           <a:p>
             <a:pPr algn="ctr">
@@ -8220,10 +8409,10 @@
   <a:themeElements>
     <a:clrScheme name="Office">
       <a:dk1>
-        <a:sysClr val="windowText" lastClr="000000"/>
+        <a:sysClr val="windowText" lastClr="C6C6C6"/>
       </a:dk1>
       <a:lt1>
-        <a:sysClr val="window" lastClr="FFFFFF"/>
+        <a:sysClr val="window" lastClr="000000"/>
       </a:lt1>
       <a:dk2>
         <a:srgbClr val="1F497D"/>

</xml_diff>